<commit_message>
Slides: architecture shows the Ingress on the node public IP (no load balancer on this account)
</commit_message>
<xml_diff>
--- a/session21-python/demo/GearLoan-presentation.pptx
+++ b/session21-python/demo/GearLoan-presentation.pptx
@@ -118,18 +118,18 @@
   <p:extLst>
     <p:ext uri="{521415D9-36F7-43E2-AB2F-B90AF26B5E84}">
       <p14:sectionLst xmlns:p14="http://schemas.microsoft.com/office/powerpoint/2010/main">
-        <p14:section name="Intro" id="{8cbf5b9a-2ef0-42c8-1089-2014232623b2}">
+        <p14:section name="Intro" id="{93bbe0ee-2366-c585-4c04-8262ec19e60c}">
           <p14:sldIdLst>
             <p14:sldId id="256"/>
           </p14:sldIdLst>
         </p14:section>
-        <p14:section name="The app" id="{74f162a0-8525-4ba5-211c-8c273ff61187}">
+        <p14:section name="The app" id="{ac36d390-8d3d-2c80-52cf-3618b81ae0e4}">
           <p14:sldIdLst>
             <p14:sldId id="257"/>
             <p14:sldId id="258"/>
           </p14:sldIdLst>
         </p14:section>
-        <p14:section name="DevOps" id="{830a382c-7904-2857-0e2d-fcb7aa916ef1}">
+        <p14:section name="DevOps" id="{dd4de8e8-985d-4085-462d-994e686c6ed5}">
           <p14:sldIdLst>
             <p14:sldId id="259"/>
             <p14:sldId id="260"/>
@@ -141,7 +141,7 @@
             <p14:sldId id="266"/>
           </p14:sldIdLst>
         </p14:section>
-        <p14:section name="Close" id="{02c274e6-c7e2-33d0-123e-c167b7507204}">
+        <p14:section name="Close" id="{c93ad1a5-e2f7-7481-76db-ae9ae11cf43b}">
           <p14:sldIdLst>
             <p14:sldId id="267"/>
           </p14:sldIdLst>
@@ -6213,7 +6213,7 @@
                   <a:schemeClr val="bg1"/>
                 </a:solidFill>
               </a:rPr>
-              <a:t>AWS NLB</a:t>
+              <a:t>node public IP :30080</a:t>
             </a:r>
             <a:endParaRPr lang="en-US" sz="1150" dirty="0"/>
           </a:p>

</xml_diff>